<commit_message>
Enforce magic-byte upload signatures & default encrypted vault, rebuild PPTX deck & clarify CI/OOD/ERP disclosures
</commit_message>
<xml_diff>
--- a/docs/deck/VidyutFlow_PS000125.pptx
+++ b/docs/deck/VidyutFlow_PS000125.pptx
@@ -513,7 +513,7 @@
           <a:lstStyle/>
           <a:p>
             <a:r>
-              <a:t>30-second opener: one flow that removes re-entry, manual routing and blind SLA firefighting — with honest AI that assists, never decides.</a:t>
+              <a:t>30-second opener: non-invasive orchestration across citizen portal, field PWA, and simulated ERP adapters — AI advises, officers decide.</a:t>
             </a:r>
           </a:p>
         </p:txBody>
@@ -583,7 +583,7 @@
           <a:lstStyle/>
           <a:p>
             <a:r>
-              <a:t>This slide pre-empts 'did you cover our PS?'. Pull up REQUIREMENT_MAPPING.md if asked for any row.</a:t>
+              <a:t>Reproduce anytime via `make train`. Rolling runtime p50/p95/p99 latency is exposed live on GET /v1/system/performance.</a:t>
             </a:r>
           </a:p>
         </p:txBody>
@@ -653,7 +653,7 @@
           <a:lstStyle/>
           <a:p>
             <a:r>
-              <a:t>Answer to outcome 8/10 lives here: hardware and DR are a proposal, the software runs on Compose today.</a:t>
+              <a:t>CI template at docs/ci.yml mirrors `make coverage`, `make train`, `make dr-proof`, and `make build`.</a:t>
             </a:r>
           </a:p>
         </p:txBody>
@@ -723,7 +723,7 @@
           <a:lstStyle/>
           <a:p>
             <a:r>
-              <a:t>Close on the measurement plan, not on claims. Q&amp;A sheet: docs/DEFENCE_QA.md — every member has a copy.</a:t>
+              <a:t>Close on disciplined measurement and zero-disruption pilot deployment.</a:t>
             </a:r>
           </a:p>
         </p:txBody>
@@ -793,7 +793,7 @@
           <a:lstStyle/>
           <a:p>
             <a:r>
-              <a:t>Name PS points verbally. The 4-8h routing figure is a design-document planning assumption — label it if asked.</a:t>
+              <a:t>Emphasize that PS000125 covers BOTH software orchestration AND IT infrastructure/DR/security.</a:t>
             </a:r>
           </a:p>
         </p:txBody>
@@ -863,7 +863,7 @@
           <a:lstStyle/>
           <a:p>
             <a:r>
-              <a:t>Emphasise: ML triages and explains; the officer decides. Core invariant.</a:t>
+              <a:t>Always state clearly in viva: the ERP gateway is OData v4-compatible and runs against a deterministic simulated in-repo target today — ready for UGVCL sandbox credentials, never claimed as live-integrated.</a:t>
             </a:r>
           </a:p>
         </p:txBody>
@@ -933,7 +933,7 @@
           <a:lstStyle/>
           <a:p>
             <a:r>
-              <a:t>Point at the grey dashed box FIRST: everything grey is honestly roadmap. API contracts stay stable while engines change.</a:t>
+              <a:t>Vendor SKUs and datasheets documented in docs/INFRASTRUCTURE_BOM_SOURCES.md (Element14, Evelta, Dell R650xs, FortiGate 60F).</a:t>
             </a:r>
           </a:p>
         </p:txBody>
@@ -1003,7 +1003,7 @@
           <a:lstStyle/>
           <a:p>
             <a:r>
-              <a:t>Say: 'this is the live API — one credential set covers portal and API'. Screenshot placeholders to be filled by Utsav.</a:t>
+              <a:t>Demo airplane mode -&gt; queue field inspection -&gt; reconnect -&gt; sync twice -&gt; prove idempotency.</a:t>
             </a:r>
           </a:p>
         </p:txBody>
@@ -1073,7 +1073,7 @@
           <a:lstStyle/>
           <a:p>
             <a:r>
-              <a:t>Live the demo step: airplane-mode → queue → sync → sync again. Then mention the restore drill as the data-permanence story.</a:t>
+              <a:t>Evidence in docs/verification/r4-cold-start-dr-proof.txt and r4-dr-failover-drill.txt.</a:t>
             </a:r>
           </a:p>
         </p:txBody>
@@ -1143,7 +1143,7 @@
           <a:lstStyle/>
           <a:p>
             <a:r>
-              <a:t>Say the honesty script VERBATIM from ML_REPORT.md. Safety guardrail escalates unknown danger phrasing conservatively.</a:t>
+              <a:t>Be explicit: 0.8824 is held-out synthetic templates; 0.9074 (49/54) is our team-authored zero-overlap OOD sanity-check set grounded in public GERC/CGRF terminology, not independent utility data.</a:t>
             </a:r>
           </a:p>
         </p:txBody>
@@ -1213,7 +1213,7 @@
           <a:lstStyle/>
           <a:p>
             <a:r>
-              <a:t>If challenged on localStorage JWT: 'documented prototype trade-off; production moves to HttpOnly cookies — listed in SECURITY.md'.</a:t>
+              <a:t>Works 100% air-gapped without GEMINI_API_KEY.</a:t>
             </a:r>
           </a:p>
         </p:txBody>
@@ -1283,7 +1283,7 @@
           <a:lstStyle/>
           <a:p>
             <a:r>
-              <a:t>Never say 'accuracy is X for UGVCL'. Reproduce: make train (byte-identical metrics.json).</a:t>
+              <a:t>Live verification endpoint: GET /v1/system/security-posture and tests/test_document_upload_validation.py.</a:t>
             </a:r>
           </a:p>
         </p:txBody>
@@ -4305,8 +4305,8 @@
         </p:nvSpPr>
         <p:spPr>
           <a:xfrm>
-            <a:off x="548640" y="1645920"/>
-            <a:ext cx="11064240" cy="4937760"/>
+            <a:off x="548640" y="1554480"/>
+            <a:ext cx="11064240" cy="5029200"/>
           </a:xfrm>
           <a:prstGeom prst="rect">
             <a:avLst/>
@@ -4323,7 +4323,7 @@
               <a:spcAft>
                 <a:spcPts val="600"/>
               </a:spcAft>
-              <a:defRPr sz="2400" b="1">
+              <a:defRPr sz="2300" b="1">
                 <a:solidFill>
                   <a:srgbClr val="E2E8F0"/>
                 </a:solidFill>
@@ -4338,14 +4338,14 @@
               <a:spcAft>
                 <a:spcPts val="600"/>
               </a:spcAft>
-              <a:defRPr sz="2400" b="1">
+              <a:defRPr sz="2300" b="1">
                 <a:solidFill>
                   <a:srgbClr val="34D399"/>
                 </a:solidFill>
               </a:defRPr>
             </a:pPr>
             <a:r>
-              <a:t>Cloud-to-Edge Orchestration for Power Utilities</a:t>
+              <a:t>Cloud-to-Edge Orchestration, Predictive AI &amp; ERP Gateway for Power Utilities</a:t>
             </a:r>
           </a:p>
           <a:p>
@@ -4353,14 +4353,14 @@
               <a:spcAft>
                 <a:spcPts val="600"/>
               </a:spcAft>
-              <a:defRPr sz="2400" b="0">
+              <a:defRPr sz="2300" b="0">
                 <a:solidFill>
                   <a:srgbClr val="E2E8F0"/>
                 </a:solidFill>
               </a:defRPr>
             </a:pPr>
             <a:r>
-              <a:t>“Enter Once, Use Everywhere”</a:t>
+              <a:t>“Enter Once, Propagate Everywhere”</a:t>
             </a:r>
           </a:p>
           <a:p>
@@ -4368,7 +4368,7 @@
               <a:spcAft>
                 <a:spcPts val="600"/>
               </a:spcAft>
-              <a:defRPr sz="2400" b="0">
+              <a:defRPr sz="2300" b="0">
                 <a:solidFill>
                   <a:srgbClr val="E2E8F0"/>
                 </a:solidFill>
@@ -4380,7 +4380,7 @@
               <a:spcAft>
                 <a:spcPts val="600"/>
               </a:spcAft>
-              <a:defRPr sz="2400" b="0">
+              <a:defRPr sz="2300" b="0">
                 <a:solidFill>
                   <a:srgbClr val="94A3B8"/>
                 </a:solidFill>
@@ -4395,7 +4395,7 @@
               <a:spcAft>
                 <a:spcPts val="600"/>
               </a:spcAft>
-              <a:defRPr sz="2400" b="0">
+              <a:defRPr sz="2300" b="0">
                 <a:solidFill>
                   <a:srgbClr val="94A3B8"/>
                 </a:solidFill>
@@ -4410,7 +4410,7 @@
               <a:spcAft>
                 <a:spcPts val="600"/>
               </a:spcAft>
-              <a:defRPr sz="2400" b="0">
+              <a:defRPr sz="2300" b="0">
                 <a:solidFill>
                   <a:srgbClr val="94A3B8"/>
                 </a:solidFill>
@@ -4471,28 +4471,76 @@
           <a:lstStyle/>
           <a:p>
             <a:pPr>
-              <a:defRPr sz="3000" b="1">
+              <a:defRPr sz="2900" b="1">
                 <a:solidFill>
                   <a:srgbClr val="E2E8F0"/>
                 </a:solidFill>
               </a:defRPr>
             </a:pPr>
             <a:r>
-              <a:t>Requirement → solution map (PS000125)</a:t>
-            </a:r>
-          </a:p>
-        </p:txBody>
-      </p:sp>
-      <p:sp>
-        <p:nvSpPr>
-          <p:cNvPr id="3" name="TextBox 2"/>
+              <a:t>ML evaluation charts — SYNTHETIC data (labelled)</a:t>
+            </a:r>
+          </a:p>
+        </p:txBody>
+      </p:sp>
+      <p:pic>
+        <p:nvPicPr>
+          <p:cNvPr id="3" name="Picture 2" descr="ml_confusion_matrices.png"/>
+          <p:cNvPicPr>
+            <a:picLocks noChangeAspect="1"/>
+          </p:cNvPicPr>
+          <p:nvPr/>
+        </p:nvPicPr>
+        <p:blipFill>
+          <a:blip r:embed="rId2"/>
+          <a:stretch>
+            <a:fillRect/>
+          </a:stretch>
+        </p:blipFill>
+        <p:spPr>
+          <a:xfrm>
+            <a:off x="457200" y="1234440"/>
+            <a:ext cx="5669280" cy="2805174"/>
+          </a:xfrm>
+          <a:prstGeom prst="rect">
+            <a:avLst/>
+          </a:prstGeom>
+        </p:spPr>
+      </p:pic>
+      <p:pic>
+        <p:nvPicPr>
+          <p:cNvPr id="4" name="Picture 3" descr="ml_risk_distribution.png"/>
+          <p:cNvPicPr>
+            <a:picLocks noChangeAspect="1"/>
+          </p:cNvPicPr>
+          <p:nvPr/>
+        </p:nvPicPr>
+        <p:blipFill>
+          <a:blip r:embed="rId3"/>
+          <a:stretch>
+            <a:fillRect/>
+          </a:stretch>
+        </p:blipFill>
+        <p:spPr>
+          <a:xfrm>
+            <a:off x="6309360" y="1234440"/>
+            <a:ext cx="5669280" cy="2248282"/>
+          </a:xfrm>
+          <a:prstGeom prst="rect">
+            <a:avLst/>
+          </a:prstGeom>
+        </p:spPr>
+      </p:pic>
+      <p:sp>
+        <p:nvSpPr>
+          <p:cNvPr id="5" name="TextBox 4"/>
           <p:cNvSpPr txBox="1"/>
           <p:nvPr/>
         </p:nvSpPr>
         <p:spPr>
           <a:xfrm>
-            <a:off x="548640" y="1371600"/>
-            <a:ext cx="11064240" cy="4937760"/>
+            <a:off x="548640" y="5166360"/>
+            <a:ext cx="11064240" cy="5029200"/>
           </a:xfrm>
           <a:prstGeom prst="rect">
             <a:avLst/>
@@ -4509,14 +4557,14 @@
               <a:spcAft>
                 <a:spcPts val="600"/>
               </a:spcAft>
-              <a:defRPr sz="1700" b="1">
-                <a:solidFill>
-                  <a:srgbClr val="34D399"/>
+              <a:defRPr sz="1300" b="1">
+                <a:solidFill>
+                  <a:srgbClr val="E2E8F0"/>
                 </a:solidFill>
               </a:defRPr>
             </a:pPr>
             <a:r>
-              <a:t>12 problem points: 7 fully built · 4 lite/partial · 1 proposal-only (hardware)</a:t>
+              <a:t>Unseen-template synthetic: Category 0.8824 (vs 0.1667) · Severity 0.8750 · SLA 0.8350 acc / 0.8913 recall</a:t>
             </a:r>
           </a:p>
           <a:p>
@@ -4524,56 +4572,14 @@
               <a:spcAft>
                 <a:spcPts val="600"/>
               </a:spcAft>
-              <a:defRPr sz="1700" b="1">
-                <a:solidFill>
-                  <a:srgbClr val="34D399"/>
+              <a:defRPr sz="1300" b="0">
+                <a:solidFill>
+                  <a:srgbClr val="F59E0B"/>
                 </a:solidFill>
               </a:defRPr>
             </a:pPr>
             <a:r>
-              <a:t>14 expected outcomes: 12 met · 1 measured-claim kept as target (productivity) · 1 hardware/DR as proposal</a:t>
-            </a:r>
-          </a:p>
-          <a:p>
-            <a:pPr>
-              <a:spcAft>
-                <a:spcPts val="600"/>
-              </a:spcAft>
-              <a:defRPr sz="1700" b="0">
-                <a:solidFill>
-                  <a:srgbClr val="E2E8F0"/>
-                </a:solidFill>
-              </a:defRPr>
-            </a:pPr>
-          </a:p>
-          <a:p>
-            <a:pPr>
-              <a:spcAft>
-                <a:spcPts val="600"/>
-              </a:spcAft>
-              <a:defRPr sz="1700" b="0">
-                <a:solidFill>
-                  <a:srgbClr val="E2E8F0"/>
-                </a:solidFill>
-              </a:defRPr>
-            </a:pPr>
-            <a:r>
-              <a:t>Every row has named evidence in REQUIREMENT_MAPPING.md (built / lite / roadmap)</a:t>
-            </a:r>
-          </a:p>
-          <a:p>
-            <a:pPr>
-              <a:spcAft>
-                <a:spcPts val="600"/>
-              </a:spcAft>
-              <a:defRPr sz="1700" b="0">
-                <a:solidFill>
-                  <a:srgbClr val="E2E8F0"/>
-                </a:solidFill>
-              </a:defRPr>
-            </a:pPr>
-            <a:r>
-              <a:t>We never claim a roadmap item as built — that rule is written into the repo</a:t>
+              <a:t>Team-authored 54-item OOD sanity check (0 synthetic overlap): 0.9074 acc (49/54) · 100% CRITICAL recall</a:t>
             </a:r>
           </a:p>
         </p:txBody>
@@ -4627,14 +4633,14 @@
           <a:lstStyle/>
           <a:p>
             <a:pPr>
-              <a:defRPr sz="3000" b="1">
+              <a:defRPr sz="2900" b="1">
                 <a:solidFill>
                   <a:srgbClr val="E2E8F0"/>
                 </a:solidFill>
               </a:defRPr>
             </a:pPr>
             <a:r>
-              <a:t>Roadmap &amp; scale-up (contracts stay stable)</a:t>
+              <a:t>100% API test coverage &amp; phased UGVCL rollout</a:t>
             </a:r>
           </a:p>
         </p:txBody>
@@ -4647,8 +4653,8 @@
         </p:nvSpPr>
         <p:spPr>
           <a:xfrm>
-            <a:off x="548640" y="1371600"/>
-            <a:ext cx="11064240" cy="4937760"/>
+            <a:off x="548640" y="1325880"/>
+            <a:ext cx="11064240" cy="5029200"/>
           </a:xfrm>
           <a:prstGeom prst="rect">
             <a:avLst/>
@@ -4665,14 +4671,14 @@
               <a:spcAft>
                 <a:spcPts val="600"/>
               </a:spcAft>
-              <a:defRPr sz="1600" b="0">
-                <a:solidFill>
-                  <a:srgbClr val="E2E8F0"/>
+              <a:defRPr sz="1500" b="1">
+                <a:solidFill>
+                  <a:srgbClr val="34D399"/>
                 </a:solidFill>
               </a:defRPr>
             </a:pPr>
             <a:r>
-              <a:t>1. Legacy ERP adapters (billing/HR/SCADA wrappers) — first item</a:t>
+              <a:t>124 backend pytest tests · 55 / 55 (100%) OpenAPI HTTP operations tested · 38 frontend test suites</a:t>
             </a:r>
           </a:p>
           <a:p>
@@ -4680,29 +4686,26 @@
               <a:spcAft>
                 <a:spcPts val="600"/>
               </a:spcAft>
-              <a:defRPr sz="1600" b="0">
+              <a:defRPr sz="1500" b="0">
                 <a:solidFill>
                   <a:srgbClr val="E2E8F0"/>
                 </a:solidFill>
               </a:defRPr>
             </a:pPr>
-            <a:r>
-              <a:t>2. Kafka / Temporal orchestration · WebSockets · GraphQL + GIS</a:t>
-            </a:r>
           </a:p>
           <a:p>
             <a:pPr>
               <a:spcAft>
                 <a:spcPts val="600"/>
               </a:spcAft>
-              <a:defRPr sz="1600" b="0">
+              <a:defRPr sz="1500" b="0">
                 <a:solidFill>
                   <a:srgbClr val="E2E8F0"/>
                 </a:solidFill>
               </a:defRPr>
             </a:pPr>
             <a:r>
-              <a:t>3. Flutter/Couchbase edge client · on-device inference</a:t>
+              <a:t>Phase 1 — 1 Subdivision Pilot (₹14.80 Lakh): UGVCL sandbox OData credentials + governed historical ML retrain</a:t>
             </a:r>
           </a:p>
           <a:p>
@@ -4710,14 +4713,14 @@
               <a:spcAft>
                 <a:spcPts val="600"/>
               </a:spcAft>
-              <a:defRPr sz="1600" b="0">
+              <a:defRPr sz="1500" b="0">
                 <a:solidFill>
                   <a:srgbClr val="E2E8F0"/>
                 </a:solidFill>
               </a:defRPr>
             </a:pPr>
             <a:r>
-              <a:t>4. Fine-tuned LLM in VPC · Zero Trust · multi-AZ DR · Vault · WAF · SSO</a:t>
+              <a:t>Phase 2 — 1 Circle HA Deployment (₹1.18 Crore): PostgreSQL 16 streaming HA + 60 substation edge gateways</a:t>
             </a:r>
           </a:p>
           <a:p>
@@ -4725,41 +4728,14 @@
               <a:spcAft>
                 <a:spcPts val="600"/>
               </a:spcAft>
-              <a:defRPr sz="1600" b="0">
+              <a:defRPr sz="1500" b="0">
                 <a:solidFill>
                   <a:srgbClr val="E2E8F0"/>
                 </a:solidFill>
               </a:defRPr>
             </a:pPr>
             <a:r>
-              <a:t>5. Hardware modernisation tiers — costed proposal (INFRASTRUCTURE_ROADMAP.md)</a:t>
-            </a:r>
-          </a:p>
-          <a:p>
-            <a:pPr>
-              <a:spcAft>
-                <a:spcPts val="600"/>
-              </a:spcAft>
-              <a:defRPr sz="1600" b="0">
-                <a:solidFill>
-                  <a:srgbClr val="E2E8F0"/>
-                </a:solidFill>
-              </a:defRPr>
-            </a:pPr>
-          </a:p>
-          <a:p>
-            <a:pPr>
-              <a:spcAft>
-                <a:spcPts val="600"/>
-              </a:spcAft>
-              <a:defRPr sz="1600" b="0">
-                <a:solidFill>
-                  <a:srgbClr val="94A3B8"/>
-                </a:solidFill>
-              </a:defRPr>
-            </a:pPr>
-            <a:r>
-              <a:t>The frozen API contract (20 ops) lets engines change without touching the workflow</a:t>
+              <a:t>Phase 3 — Full DISCOM Scale-Out (₹7.45 Crore): 4 Circles, 500× RPi4 4G edge nodes, active-passive DC/DR</a:t>
             </a:r>
           </a:p>
         </p:txBody>
@@ -4813,14 +4789,14 @@
           <a:lstStyle/>
           <a:p>
             <a:pPr>
-              <a:defRPr sz="3000" b="1">
+              <a:defRPr sz="2900" b="1">
                 <a:solidFill>
                   <a:srgbClr val="E2E8F0"/>
                 </a:solidFill>
               </a:defRPr>
             </a:pPr>
             <a:r>
-              <a:t>Team &amp; next steps</a:t>
+              <a:t>Team ownership &amp; pilot ask</a:t>
             </a:r>
           </a:p>
         </p:txBody>
@@ -4833,8 +4809,8 @@
         </p:nvSpPr>
         <p:spPr>
           <a:xfrm>
-            <a:off x="548640" y="1371600"/>
-            <a:ext cx="11064240" cy="4937760"/>
+            <a:off x="548640" y="1325880"/>
+            <a:ext cx="11064240" cy="5029200"/>
           </a:xfrm>
           <a:prstGeom prst="rect">
             <a:avLst/>
@@ -4851,14 +4827,14 @@
               <a:spcAft>
                 <a:spcPts val="600"/>
               </a:spcAft>
-              <a:defRPr sz="1700" b="0">
+              <a:defRPr sz="1600" b="0">
                 <a:solidFill>
                   <a:srgbClr val="E2E8F0"/>
                 </a:solidFill>
               </a:defRPr>
             </a:pPr>
             <a:r>
-              <a:t>R1 Backend &amp; Workflow — Yogesh (Lead) · R2 Frontend &amp; PWA — Utsav</a:t>
+              <a:t>R1 Backend, Workflow &amp; ERP Gateway — Yogesh (Lead) · R2 Multilingual Portals &amp; Offline PWA — Utsav</a:t>
             </a:r>
           </a:p>
           <a:p>
@@ -4866,14 +4842,14 @@
               <a:spcAft>
                 <a:spcPts val="600"/>
               </a:spcAft>
-              <a:defRPr sz="1700" b="0">
+              <a:defRPr sz="1600" b="0">
                 <a:solidFill>
                   <a:srgbClr val="E2E8F0"/>
                 </a:solidFill>
               </a:defRPr>
             </a:pPr>
             <a:r>
-              <a:t>R3 ML &amp; AI — Aakash · R4 DevOps/Security/QA — Sandip · R5 Docs &amp; Demo — Arnav</a:t>
+              <a:t>R3 5-Model ML Suite &amp; Policy RAG — Aakash · R4 Security, AES-256 Vault &amp; DR — Sandip · R5 Infra BOM &amp; QA — Arnav</a:t>
             </a:r>
           </a:p>
           <a:p>
@@ -4881,7 +4857,7 @@
               <a:spcAft>
                 <a:spcPts val="600"/>
               </a:spcAft>
-              <a:defRPr sz="1700" b="0">
+              <a:defRPr sz="1600" b="0">
                 <a:solidFill>
                   <a:srgbClr val="E2E8F0"/>
                 </a:solidFill>
@@ -4893,14 +4869,14 @@
               <a:spcAft>
                 <a:spcPts val="600"/>
               </a:spcAft>
-              <a:defRPr sz="1700" b="1">
+              <a:defRPr sz="1600" b="1">
                 <a:solidFill>
                   <a:srgbClr val="34D399"/>
                 </a:solidFill>
               </a:defRPr>
             </a:pPr>
             <a:r>
-              <a:t>Pilot plan: governed UGVCL data → retrain → re-baseline → before/after timing study</a:t>
+              <a:t>Pilot ask: 1 UGVCL subdivision sandbox + anonymized historical tickets to re-baseline productivity &amp; SLA lift</a:t>
             </a:r>
           </a:p>
           <a:p>
@@ -4908,41 +4884,14 @@
               <a:spcAft>
                 <a:spcPts val="600"/>
               </a:spcAft>
-              <a:defRPr sz="1700" b="0">
-                <a:solidFill>
-                  <a:srgbClr val="E2E8F0"/>
+              <a:defRPr sz="1600" b="0">
+                <a:solidFill>
+                  <a:srgbClr val="94A3B8"/>
                 </a:solidFill>
               </a:defRPr>
             </a:pPr>
             <a:r>
-              <a:t>That study is how outcome 13 (productivity) becomes a measured number</a:t>
-            </a:r>
-          </a:p>
-          <a:p>
-            <a:pPr>
-              <a:spcAft>
-                <a:spcPts val="600"/>
-              </a:spcAft>
-              <a:defRPr sz="1700" b="0">
-                <a:solidFill>
-                  <a:srgbClr val="E2E8F0"/>
-                </a:solidFill>
-              </a:defRPr>
-            </a:pPr>
-          </a:p>
-          <a:p>
-            <a:pPr>
-              <a:spcAft>
-                <a:spcPts val="600"/>
-              </a:spcAft>
-              <a:defRPr sz="1700" b="1">
-                <a:solidFill>
-                  <a:srgbClr val="E2E8F0"/>
-                </a:solidFill>
-              </a:defRPr>
-            </a:pPr>
-            <a:r>
-              <a:t>Ask: approval for a scoped pilot on one subdivision's new-connection flow</a:t>
+              <a:t>Full defence Q&amp;A &amp; module walkthroughs: docs/DEFENCE_QA.md &amp; docs/TEAM_COMMIT_AND_VIVA_PLAN.md</a:t>
             </a:r>
           </a:p>
         </p:txBody>
@@ -4996,14 +4945,14 @@
           <a:lstStyle/>
           <a:p>
             <a:pPr>
-              <a:defRPr sz="3000" b="1">
+              <a:defRPr sz="2900" b="1">
                 <a:solidFill>
                   <a:srgbClr val="E2E8F0"/>
                 </a:solidFill>
               </a:defRPr>
             </a:pPr>
             <a:r>
-              <a:t>The problem — PS000125 pain points</a:t>
+              <a:t>The problem — PS000125 operational silos</a:t>
             </a:r>
           </a:p>
         </p:txBody>
@@ -5016,8 +4965,8 @@
         </p:nvSpPr>
         <p:spPr>
           <a:xfrm>
-            <a:off x="548640" y="1371600"/>
-            <a:ext cx="11064240" cy="4937760"/>
+            <a:off x="548640" y="1325880"/>
+            <a:ext cx="11064240" cy="5029200"/>
           </a:xfrm>
           <a:prstGeom prst="rect">
             <a:avLst/>
@@ -5034,14 +4983,14 @@
               <a:spcAft>
                 <a:spcPts val="600"/>
               </a:spcAft>
-              <a:defRPr sz="1800" b="1">
+              <a:defRPr sz="1700" b="1">
                 <a:solidFill>
                   <a:srgbClr val="E2E8F0"/>
                 </a:solidFill>
               </a:defRPr>
             </a:pPr>
             <a:r>
-              <a:t>Same applicant details re-typed across ERP, portals and field systems</a:t>
+              <a:t>Disconnected Citizen Portal ↔ SAP Finance/IS-U ↔ e-Urja Billing ↔ 1912 Grievance CRM</a:t>
             </a:r>
           </a:p>
           <a:p>
@@ -5049,14 +4998,14 @@
               <a:spcAft>
                 <a:spcPts val="600"/>
               </a:spcAft>
-              <a:defRPr sz="1800" b="0">
+              <a:defRPr sz="1700" b="0">
                 <a:solidFill>
                   <a:srgbClr val="E2E8F0"/>
                 </a:solidFill>
               </a:defRPr>
             </a:pPr>
             <a:r>
-              <a:t>Requests moved manually between desks — routing takes hours (planning assumption), files stall</a:t>
+              <a:t>Applicant details re-keyed across desks; manual routing stalls files</a:t>
             </a:r>
           </a:p>
           <a:p>
@@ -5064,14 +5013,14 @@
               <a:spcAft>
                 <a:spcPts val="600"/>
               </a:spcAft>
-              <a:defRPr sz="1800" b="0">
+              <a:defRPr sz="1700" b="0">
                 <a:solidFill>
                   <a:srgbClr val="E2E8F0"/>
                 </a:solidFill>
               </a:defRPr>
             </a:pPr>
             <a:r>
-              <a:t>Field work stops without network; naive re-sync creates duplicates</a:t>
+              <a:t>Rural North Gujarat 2G/4G dead-zones halt field inspections; naive retries duplicate records</a:t>
             </a:r>
           </a:p>
           <a:p>
@@ -5079,14 +5028,14 @@
               <a:spcAft>
                 <a:spcPts val="600"/>
               </a:spcAft>
-              <a:defRPr sz="1800" b="0">
+              <a:defRPr sz="1700" b="0">
                 <a:solidFill>
                   <a:srgbClr val="E2E8F0"/>
                 </a:solidFill>
               </a:defRPr>
             </a:pPr>
             <a:r>
-              <a:t>SLA breaches discovered after the deadline; consumers visit offices for status</a:t>
+              <a:t>Reactive SLA breach discovery &amp; legacy infrastructure / DR / security gaps</a:t>
             </a:r>
           </a:p>
           <a:p>
@@ -5094,7 +5043,7 @@
               <a:spcAft>
                 <a:spcPts val="600"/>
               </a:spcAft>
-              <a:defRPr sz="1800" b="0">
+              <a:defRPr sz="1700" b="0">
                 <a:solidFill>
                   <a:srgbClr val="E2E8F0"/>
                 </a:solidFill>
@@ -5106,14 +5055,14 @@
               <a:spcAft>
                 <a:spcPts val="600"/>
               </a:spcAft>
-              <a:defRPr sz="1800" b="0">
+              <a:defRPr sz="1700" b="0">
                 <a:solidFill>
                   <a:srgbClr val="94A3B8"/>
                 </a:solidFill>
               </a:defRPr>
             </a:pPr>
             <a:r>
-              <a:t>PS points addressed head-on: 1, 2, 3, 4, 5, 8, 9, 11 (full map: REQUIREMENT_MAPPING.md)</a:t>
+              <a:t>Full 12-point problem &amp; 14-outcome coverage matrix: docs/REQUIREMENT_MAPPING.md</a:t>
             </a:r>
           </a:p>
         </p:txBody>
@@ -5167,14 +5116,14 @@
           <a:lstStyle/>
           <a:p>
             <a:pPr>
-              <a:defRPr sz="3000" b="1">
+              <a:defRPr sz="2900" b="1">
                 <a:solidFill>
                   <a:srgbClr val="E2E8F0"/>
                 </a:solidFill>
               </a:defRPr>
             </a:pPr>
             <a:r>
-              <a:t>VidyutFlow — one click-and-get-work-done flow</a:t>
+              <a:t>Non-invasive ERP gateway (OData v4-compatible, simulated)</a:t>
             </a:r>
           </a:p>
         </p:txBody>
@@ -5187,8 +5136,8 @@
         </p:nvSpPr>
         <p:spPr>
           <a:xfrm>
-            <a:off x="548640" y="1371600"/>
-            <a:ext cx="11064240" cy="4937760"/>
+            <a:off x="548640" y="1325880"/>
+            <a:ext cx="11064240" cy="5029200"/>
           </a:xfrm>
           <a:prstGeom prst="rect">
             <a:avLst/>
@@ -5205,14 +5154,14 @@
               <a:spcAft>
                 <a:spcPts val="600"/>
               </a:spcAft>
-              <a:defRPr sz="1700" b="1">
+              <a:defRPr sz="1600" b="1">
                 <a:solidFill>
                   <a:srgbClr val="34D399"/>
                 </a:solidFill>
               </a:defRPr>
             </a:pPr>
             <a:r>
-              <a:t>SUBMIT → VALIDATE → CLASSIFY (ML) → SLA-RISK (ML) → ROUTE &amp; ASSIGN → FIELD (offline) → DECIDE</a:t>
+              <a:t>NEVER rips or replaces existing DISCOM core systems (replaces_existing_erp = False)</a:t>
             </a:r>
           </a:p>
           <a:p>
@@ -5220,7 +5169,7 @@
               <a:spcAft>
                 <a:spcPts val="600"/>
               </a:spcAft>
-              <a:defRPr sz="1700" b="0">
+              <a:defRPr sz="1600" b="0">
                 <a:solidFill>
                   <a:srgbClr val="E2E8F0"/>
                 </a:solidFill>
@@ -5232,14 +5181,14 @@
               <a:spcAft>
                 <a:spcPts val="600"/>
               </a:spcAft>
-              <a:defRPr sz="1700" b="0">
+              <a:defRPr sz="1600" b="0">
                 <a:solidFill>
                   <a:srgbClr val="E2E8F0"/>
                 </a:solidFill>
               </a:defRPr>
             </a:pPr>
             <a:r>
-              <a:t>Consumer submits once — the SAME record feeds officer queue, engineer task, admin KPIs</a:t>
+              <a:t>12 citizen fields entered once → 0 staff re-typed fields across workflow &amp; gateway</a:t>
             </a:r>
           </a:p>
           <a:p>
@@ -5247,14 +5196,14 @@
               <a:spcAft>
                 <a:spcPts val="600"/>
               </a:spcAft>
-              <a:defRPr sz="1700" b="0">
+              <a:defRPr sz="1600" b="0">
                 <a:solidFill>
                   <a:srgbClr val="E2E8F0"/>
                 </a:solidFill>
               </a:defRPr>
             </a:pPr>
             <a:r>
-              <a:t>Rule validation + ML triage run automatically; SLA clock starts at submit</a:t>
+              <a:t>Simulated OData v4-compatible SAP S/4HANA IS-U adapter (/v1/erp/sap-odata/*)</a:t>
             </a:r>
           </a:p>
           <a:p>
@@ -5262,14 +5211,14 @@
               <a:spcAft>
                 <a:spcPts val="600"/>
               </a:spcAft>
-              <a:defRPr sz="1700" b="0">
+              <a:defRPr sz="1600" b="0">
                 <a:solidFill>
                   <a:srgbClr val="E2E8F0"/>
                 </a:solidFill>
               </a:defRPr>
             </a:pPr>
             <a:r>
-              <a:t>Field engineer works offline; sync is idempotent (each UUID accepted once)</a:t>
+              <a:t>3-system fan-out (/v1/erp/gateway/propagate/{id}) → simulated SAP + e-Urja CIS + 1912 CRM</a:t>
             </a:r>
           </a:p>
           <a:p>
@@ -5277,14 +5226,14 @@
               <a:spcAft>
                 <a:spcPts val="600"/>
               </a:spcAft>
-              <a:defRPr sz="1700" b="1">
+              <a:defRPr sz="1600" b="1">
                 <a:solidFill>
                   <a:srgbClr val="E2E8F0"/>
                 </a:solidFill>
               </a:defRPr>
             </a:pPr>
             <a:r>
-              <a:t>The officer approves/rejects — every action is audit-logged</a:t>
+              <a:t>Master-data drift detection &amp; 1-click reconciliation (/v1/erp/reconcile)</a:t>
             </a:r>
           </a:p>
         </p:txBody>
@@ -5338,14 +5287,14 @@
           <a:lstStyle/>
           <a:p>
             <a:pPr>
-              <a:defRPr sz="3000" b="1">
+              <a:defRPr sz="2900" b="1">
                 <a:solidFill>
                   <a:srgbClr val="E2E8F0"/>
                 </a:solidFill>
               </a:defRPr>
             </a:pPr>
             <a:r>
-              <a:t>Architecture — built (color) vs roadmap (grey)</a:t>
+              <a:t>Cloud-to-edge IT infrastructure &amp; costed BOM</a:t>
             </a:r>
           </a:p>
         </p:txBody>
@@ -5366,14 +5315,52 @@
         </p:blipFill>
         <p:spPr>
           <a:xfrm>
-            <a:off x="1097280" y="1234440"/>
-            <a:ext cx="9966960" cy="5803304"/>
+            <a:off x="1097280" y="1188720"/>
+            <a:ext cx="8778240" cy="5111167"/>
           </a:xfrm>
           <a:prstGeom prst="rect">
             <a:avLst/>
           </a:prstGeom>
         </p:spPr>
       </p:pic>
+      <p:sp>
+        <p:nvSpPr>
+          <p:cNvPr id="4" name="TextBox 3"/>
+          <p:cNvSpPr txBox="1"/>
+          <p:nvPr/>
+        </p:nvSpPr>
+        <p:spPr>
+          <a:xfrm>
+            <a:off x="548640" y="5806440"/>
+            <a:ext cx="11064240" cy="5029200"/>
+          </a:xfrm>
+          <a:prstGeom prst="rect">
+            <a:avLst/>
+          </a:prstGeom>
+          <a:noFill/>
+        </p:spPr>
+        <p:txBody>
+          <a:bodyPr wrap="square">
+            <a:spAutoFit/>
+          </a:bodyPr>
+          <a:lstStyle/>
+          <a:p>
+            <a:pPr>
+              <a:spcAft>
+                <a:spcPts val="600"/>
+              </a:spcAft>
+              <a:defRPr sz="1300" b="1">
+                <a:solidFill>
+                  <a:srgbClr val="34D399"/>
+                </a:solidFill>
+              </a:defRPr>
+            </a:pPr>
+            <a:r>
+              <a:t>Substation Edge: 500× RPi4 + Quectel EC200U-CN Dual-SIM 4G (₹8,000 × 500 = ₹40L) · MPLS + FortiGate 60F SD-WAN · Tiers: ₹14.80L / ₹1.18Cr / ₹7.45Cr</a:t>
+            </a:r>
+          </a:p>
+        </p:txBody>
+      </p:sp>
     </p:spTree>
   </p:cSld>
   <p:clrMapOvr>
@@ -5423,14 +5410,14 @@
           <a:lstStyle/>
           <a:p>
             <a:pPr>
-              <a:defRPr sz="3000" b="1">
+              <a:defRPr sz="2900" b="1">
                 <a:solidFill>
                   <a:srgbClr val="E2E8F0"/>
                 </a:solidFill>
               </a:defRPr>
             </a:pPr>
             <a:r>
-              <a:t>Workflow demo — the real backend, not mockups</a:t>
+              <a:t>Multi-portal workflow &amp; idempotent offline field sync</a:t>
             </a:r>
           </a:p>
         </p:txBody>
@@ -5443,8 +5430,8 @@
         </p:nvSpPr>
         <p:spPr>
           <a:xfrm>
-            <a:off x="548640" y="1371600"/>
-            <a:ext cx="11064240" cy="4937760"/>
+            <a:off x="548640" y="1325880"/>
+            <a:ext cx="11064240" cy="5029200"/>
           </a:xfrm>
           <a:prstGeom prst="rect">
             <a:avLst/>
@@ -5461,14 +5448,14 @@
               <a:spcAft>
                 <a:spcPts val="600"/>
               </a:spcAft>
-              <a:defRPr sz="1700" b="0">
+              <a:defRPr sz="1600" b="0">
                 <a:solidFill>
                   <a:srgbClr val="E2E8F0"/>
                 </a:solidFill>
               </a:defRPr>
             </a:pPr>
             <a:r>
-              <a:t>1 · Consumer wizard submit → live API returns ML category/severity + SLA risk in the toast</a:t>
+              <a:t>5 RBAC portals (Consumer, Field Engineer, Sub-Divisional Officer, Management, IT Admin)</a:t>
             </a:r>
           </a:p>
           <a:p>
@@ -5476,14 +5463,14 @@
               <a:spcAft>
                 <a:spcPts val="600"/>
               </a:spcAft>
-              <a:defRPr sz="1700" b="0">
+              <a:defRPr sz="1600" b="0">
                 <a:solidFill>
                   <a:srgbClr val="E2E8F0"/>
                 </a:solidFill>
               </a:defRPr>
             </a:pPr>
             <a:r>
-              <a:t>2 · Officer Live Request Queue — real rows, auto-refresh 45s, SLA-risk reasons visible</a:t>
+              <a:t>4 languages (English, Gujarati, Hindi, Marathi) + 7 configurable utility workflows</a:t>
             </a:r>
           </a:p>
           <a:p>
@@ -5491,14 +5478,14 @@
               <a:spcAft>
                 <a:spcPts val="600"/>
               </a:spcAft>
-              <a:defRPr sz="1700" b="0">
+              <a:defRPr sz="1600" b="0">
                 <a:solidFill>
                   <a:srgbClr val="E2E8F0"/>
                 </a:solidFill>
               </a:defRPr>
             </a:pPr>
             <a:r>
-              <a:t>3 · Management/Admin Live Workflow KPIs + SLA-Risk Watchlist (model output)</a:t>
+              <a:t>Field PWA queues inspections offline in IndexedDB with UUIDv4 client_uuid keys</a:t>
             </a:r>
           </a:p>
           <a:p>
@@ -5506,14 +5493,14 @@
               <a:spcAft>
                 <a:spcPts val="600"/>
               </a:spcAft>
-              <a:defRPr sz="1700" b="0">
-                <a:solidFill>
-                  <a:srgbClr val="E2E8F0"/>
+              <a:defRPr sz="1600" b="1">
+                <a:solidFill>
+                  <a:srgbClr val="34D399"/>
                 </a:solidFill>
               </a:defRPr>
             </a:pPr>
             <a:r>
-              <a:t>4 · Server-side alert centre: notifications on submit / status change / field sync</a:t>
+              <a:t>Replay-safe sync (/v1/requests/field-sync): duplicate replay returns duplicate:true, 0 extra rows</a:t>
             </a:r>
           </a:p>
           <a:p>
@@ -5521,26 +5508,14 @@
               <a:spcAft>
                 <a:spcPts val="600"/>
               </a:spcAft>
-              <a:defRPr sz="1700" b="0">
+              <a:defRPr sz="1600" b="0">
                 <a:solidFill>
                   <a:srgbClr val="E2E8F0"/>
                 </a:solidFill>
               </a:defRPr>
             </a:pPr>
-          </a:p>
-          <a:p>
-            <a:pPr>
-              <a:spcAft>
-                <a:spcPts val="600"/>
-              </a:spcAft>
-              <a:defRPr sz="1700" b="0">
-                <a:solidFill>
-                  <a:srgbClr val="94A3B8"/>
-                </a:solidFill>
-              </a:defRPr>
-            </a:pPr>
-            <a:r>
-              <a:t>Screenshots pack: Utsav (before video shoot) · live demo path: docs/DEMO_SCRIPT.md</a:t>
+            <a:r>
+              <a:t>Server-side SLA alert engine (/v1/notifications/evaluate-alerts) + 1-click triage</a:t>
             </a:r>
           </a:p>
         </p:txBody>
@@ -5594,14 +5569,14 @@
           <a:lstStyle/>
           <a:p>
             <a:pPr>
-              <a:defRPr sz="3000" b="1">
+              <a:defRPr sz="2900" b="1">
                 <a:solidFill>
                   <a:srgbClr val="E2E8F0"/>
                 </a:solidFill>
               </a:defRPr>
             </a:pPr>
             <a:r>
-              <a:t>Offline sync &amp; de-duplication — plus backup/restore</a:t>
+              <a:t>Cold-start &lt;60s primary → hot-standby DR failover</a:t>
             </a:r>
           </a:p>
         </p:txBody>
@@ -5614,8 +5589,8 @@
         </p:nvSpPr>
         <p:spPr>
           <a:xfrm>
-            <a:off x="548640" y="1371600"/>
-            <a:ext cx="11064240" cy="4937760"/>
+            <a:off x="548640" y="1325880"/>
+            <a:ext cx="11064240" cy="5029200"/>
           </a:xfrm>
           <a:prstGeom prst="rect">
             <a:avLst/>
@@ -5632,14 +5607,14 @@
               <a:spcAft>
                 <a:spcPts val="600"/>
               </a:spcAft>
-              <a:defRPr sz="1700" b="0">
+              <a:defRPr sz="1600" b="1">
                 <a:solidFill>
                   <a:srgbClr val="E2E8F0"/>
                 </a:solidFill>
               </a:defRPr>
             </a:pPr>
             <a:r>
-              <a:t>Field PWA queues inspections with UUIDv4 keys while offline (airplane mode)</a:t>
+              <a:t>Live API (POST /v1/system/dr-failover-drill) &amp; cold-start script (cold_start_dr_proof.py)</a:t>
             </a:r>
           </a:p>
           <a:p>
@@ -5647,29 +5622,26 @@
               <a:spcAft>
                 <a:spcPts val="600"/>
               </a:spcAft>
-              <a:defRPr sz="1700" b="0">
+              <a:defRPr sz="1600" b="0">
                 <a:solidFill>
                   <a:srgbClr val="E2E8F0"/>
                 </a:solidFill>
               </a:defRPr>
             </a:pPr>
-            <a:r>
-              <a:t>Sync is JWT-authenticated; the server accepts each UUID exactly once</a:t>
-            </a:r>
           </a:p>
           <a:p>
             <a:pPr>
               <a:spcAft>
                 <a:spcPts val="600"/>
               </a:spcAft>
-              <a:defRPr sz="1700" b="0">
+              <a:defRPr sz="1600" b="0">
                 <a:solidFill>
                   <a:srgbClr val="E2E8F0"/>
                 </a:solidFill>
               </a:defRPr>
             </a:pPr>
             <a:r>
-              <a:t>Sync twice → duplicate:true, no second row (proven by regression test + demo)</a:t>
+              <a:t>1 · Boot fresh DB &amp; submit live citizen request (zero manual container pre-setup)</a:t>
             </a:r>
           </a:p>
           <a:p>
@@ -5677,26 +5649,29 @@
               <a:spcAft>
                 <a:spcPts val="600"/>
               </a:spcAft>
-              <a:defRPr sz="1700" b="0">
+              <a:defRPr sz="1600" b="0">
                 <a:solidFill>
                   <a:srgbClr val="E2E8F0"/>
                 </a:solidFill>
               </a:defRPr>
             </a:pPr>
+            <a:r>
+              <a:t>2 · Replicate SHA-256 checksummed snapshot to isolated hot-standby vault</a:t>
+            </a:r>
           </a:p>
           <a:p>
             <a:pPr>
               <a:spcAft>
                 <a:spcPts val="600"/>
               </a:spcAft>
-              <a:defRPr sz="1700" b="1">
-                <a:solidFill>
-                  <a:srgbClr val="34D399"/>
+              <a:defRPr sz="1600" b="0">
+                <a:solidFill>
+                  <a:srgbClr val="E2E8F0"/>
                 </a:solidFill>
               </a:defRPr>
             </a:pPr>
             <a:r>
-              <a:t>Backup → checksum verify → tamper-reject → wipe → restore → live-serve drill: PASS</a:t>
+              <a:t>3 · Destroy primary DB → verify SHA-256 → promote standby → PRAGMA integrity_check = ok</a:t>
             </a:r>
           </a:p>
           <a:p>
@@ -5704,14 +5679,14 @@
               <a:spcAft>
                 <a:spcPts val="600"/>
               </a:spcAft>
-              <a:defRPr sz="1700" b="0">
-                <a:solidFill>
-                  <a:srgbClr val="94A3B8"/>
+              <a:defRPr sz="1600" b="1">
+                <a:solidFill>
+                  <a:srgbClr val="34D399"/>
                 </a:solidFill>
               </a:defRPr>
             </a:pPr>
             <a:r>
-              <a:t>Evidence: docs/verification/r4-backup-restore.txt</a:t>
+              <a:t>Measured local SQLite RTO: ~3.5 ms (&lt; 60s target) · 0 records lost</a:t>
             </a:r>
           </a:p>
         </p:txBody>
@@ -5765,14 +5740,14 @@
           <a:lstStyle/>
           <a:p>
             <a:pPr>
-              <a:defRPr sz="3000" b="1">
+              <a:defRPr sz="2900" b="1">
                 <a:solidFill>
                   <a:srgbClr val="E2E8F0"/>
                 </a:solidFill>
               </a:defRPr>
             </a:pPr>
             <a:r>
-              <a:t>AI — honest by design</a:t>
+              <a:t>5-model predictive AI suite — advisory by design</a:t>
             </a:r>
           </a:p>
         </p:txBody>
@@ -5785,8 +5760,8 @@
         </p:nvSpPr>
         <p:spPr>
           <a:xfrm>
-            <a:off x="548640" y="1371600"/>
-            <a:ext cx="11064240" cy="4937760"/>
+            <a:off x="548640" y="1325880"/>
+            <a:ext cx="11064240" cy="5029200"/>
           </a:xfrm>
           <a:prstGeom prst="rect">
             <a:avLst/>
@@ -5803,14 +5778,14 @@
               <a:spcAft>
                 <a:spcPts val="600"/>
               </a:spcAft>
-              <a:defRPr sz="1700" b="0">
+              <a:defRPr sz="1500" b="0">
                 <a:solidFill>
                   <a:srgbClr val="E2E8F0"/>
                 </a:solidFill>
               </a:defRPr>
             </a:pPr>
             <a:r>
-              <a:t>Two small scikit-learn models: category/severity classifier + SLA-breach risk with REASONS</a:t>
+              <a:t>1 · Category Classifier (TF-IDF + LogReg): 0.8824 unseen-template synthetic · 0.9074 (49/54) team-authored OOD sanity check</a:t>
             </a:r>
           </a:p>
           <a:p>
@@ -5818,14 +5793,14 @@
               <a:spcAft>
                 <a:spcPts val="600"/>
               </a:spcAft>
-              <a:defRPr sz="1700" b="0">
+              <a:defRPr sz="1500" b="0">
                 <a:solidFill>
                   <a:srgbClr val="E2E8F0"/>
                 </a:solidFill>
               </a:defRPr>
             </a:pPr>
             <a:r>
-              <a:t>TF-IDF policy assistant over 3 policy extracts — answers cite sources</a:t>
+              <a:t>2 · Severity + Deterministic Safety Guardrail: 0.8750 balanced · 100% CRITICAL safety recall</a:t>
             </a:r>
           </a:p>
           <a:p>
@@ -5833,14 +5808,14 @@
               <a:spcAft>
                 <a:spcPts val="600"/>
               </a:spcAft>
-              <a:defRPr sz="1700" b="0">
+              <a:defRPr sz="1500" b="0">
                 <a:solidFill>
                   <a:srgbClr val="E2E8F0"/>
                 </a:solidFill>
               </a:defRPr>
             </a:pPr>
             <a:r>
-              <a:t>SLA-Risk Watchlist puts model output + reasons where officers act</a:t>
+              <a:t>3 · Cost-Sensitive SLA Breach Predictor (RandomForest, thr=0.38): 0.8913 breach recall (0.8350 acc)</a:t>
             </a:r>
           </a:p>
           <a:p>
@@ -5848,26 +5823,29 @@
               <a:spcAft>
                 <a:spcPts val="600"/>
               </a:spcAft>
-              <a:defRPr sz="1700" b="0">
+              <a:defRPr sz="1500" b="0">
                 <a:solidFill>
                   <a:srgbClr val="E2E8F0"/>
                 </a:solidFill>
               </a:defRPr>
             </a:pPr>
+            <a:r>
+              <a:t>4 · Billing Anomaly Detector (IsolationForest + GERC RGPU slab verifier): 0.9511 acc / 1.00 recall</a:t>
+            </a:r>
           </a:p>
           <a:p>
             <a:pPr>
               <a:spcAft>
                 <a:spcPts val="600"/>
               </a:spcAft>
-              <a:defRPr sz="1700" b="1">
-                <a:solidFill>
-                  <a:srgbClr val="F59E0B"/>
+              <a:defRPr sz="1500" b="0">
+                <a:solidFill>
+                  <a:srgbClr val="E2E8F0"/>
                 </a:solidFill>
               </a:defRPr>
             </a:pPr>
             <a:r>
-              <a:t>SYNTHETIC training data · triage probabilities, not verdicts · officer decides, always</a:t>
+              <a:t>5 · 24h Feeder/DTR Load Forecaster (GradientBoostingRegressor): R² = 0.9790 (MAE 8.89 kVA)</a:t>
             </a:r>
           </a:p>
           <a:p>
@@ -5875,14 +5853,14 @@
               <a:spcAft>
                 <a:spcPts val="600"/>
               </a:spcAft>
-              <a:defRPr sz="1700" b="0">
-                <a:solidFill>
-                  <a:srgbClr val="94A3B8"/>
+              <a:defRPr sz="1500" b="1">
+                <a:solidFill>
+                  <a:srgbClr val="F59E0B"/>
                 </a:solidFill>
               </a:defRPr>
             </a:pPr>
             <a:r>
-              <a:t>30-second honesty script: docs/ML_REPORT.md</a:t>
+              <a:t>SYNTHETIC training data · models advise, human officers approve (models_can_approve_or_reject = False)</a:t>
             </a:r>
           </a:p>
         </p:txBody>
@@ -5936,14 +5914,14 @@
           <a:lstStyle/>
           <a:p>
             <a:pPr>
-              <a:defRPr sz="3000" b="1">
+              <a:defRPr sz="2900" b="1">
                 <a:solidFill>
                   <a:srgbClr val="E2E8F0"/>
                 </a:solidFill>
               </a:defRPr>
             </a:pPr>
             <a:r>
-              <a:t>Security — and practical accessibility</a:t>
+              <a:t>Hybrid AI — local TF-IDF RAG + optional Gemini</a:t>
             </a:r>
           </a:p>
         </p:txBody>
@@ -5956,8 +5934,8 @@
         </p:nvSpPr>
         <p:spPr>
           <a:xfrm>
-            <a:off x="548640" y="1371600"/>
-            <a:ext cx="11064240" cy="4937760"/>
+            <a:off x="548640" y="1325880"/>
+            <a:ext cx="11064240" cy="5029200"/>
           </a:xfrm>
           <a:prstGeom prst="rect">
             <a:avLst/>
@@ -5974,14 +5952,14 @@
               <a:spcAft>
                 <a:spcPts val="600"/>
               </a:spcAft>
-              <a:defRPr sz="1600" b="0">
-                <a:solidFill>
-                  <a:srgbClr val="E2E8F0"/>
+              <a:defRPr sz="1600" b="1">
+                <a:solidFill>
+                  <a:srgbClr val="34D399"/>
                 </a:solidFill>
               </a:defRPr>
             </a:pPr>
             <a:r>
-              <a:t>JWT + RBAC + assignment/zone scoping (fail-closed) · bcrypt (72-byte safe) · CORS allowlist</a:t>
+              <a:t>Zero external LLM dependency for core triage, SLA risk, billing anomaly, or policy Q&amp;A</a:t>
             </a:r>
           </a:p>
           <a:p>
@@ -5996,7 +5974,7 @@
               </a:defRPr>
             </a:pPr>
             <a:r>
-              <a:t>Tamper-evident audit log: sha256 hash chain + admin verify endpoint</a:t>
+              <a:t>Backend /v1/assistant/chat: 100% local TF-IDF retrieval over policy docs + live zone-breach SQL</a:t>
             </a:r>
           </a:p>
           <a:p>
@@ -6011,7 +5989,7 @@
               </a:defRPr>
             </a:pPr>
             <a:r>
-              <a:t>Login throttle (20/min/IP) · security headers · production guards reject dev secrets &amp; demo data</a:t>
+              <a:t>Portal /api/ai-chat: optional server-side Gemini (3,500 ms bound) → deterministic Grounded Engine fallback</a:t>
             </a:r>
           </a:p>
           <a:p>
@@ -6026,34 +6004,7 @@
               </a:defRPr>
             </a:pPr>
             <a:r>
-              <a:t>One credential set for portal + API; browser state grants nothing</a:t>
-            </a:r>
-          </a:p>
-          <a:p>
-            <a:pPr>
-              <a:spcAft>
-                <a:spcPts val="600"/>
-              </a:spcAft>
-              <a:defRPr sz="1600" b="0">
-                <a:solidFill>
-                  <a:srgbClr val="E2E8F0"/>
-                </a:solidFill>
-              </a:defRPr>
-            </a:pPr>
-          </a:p>
-          <a:p>
-            <a:pPr>
-              <a:spcAft>
-                <a:spcPts val="600"/>
-              </a:spcAft>
-              <a:defRPr sz="1600" b="0">
-                <a:solidFill>
-                  <a:srgbClr val="94A3B8"/>
-                </a:solidFill>
-              </a:defRPr>
-            </a:pPr>
-            <a:r>
-              <a:t>Known prototype gaps and their one-line defences: SECURITY.md</a:t>
+              <a:t>Live AI Governance telemetry (/v1/assistant/ai-governance): drift, OOD load caps (&gt;100 kW), human sign-off count</a:t>
             </a:r>
           </a:p>
         </p:txBody>
@@ -6107,76 +6058,28 @@
           <a:lstStyle/>
           <a:p>
             <a:pPr>
-              <a:defRPr sz="3000" b="1">
+              <a:defRPr sz="2900" b="1">
                 <a:solidFill>
                   <a:srgbClr val="E2E8F0"/>
                 </a:solidFill>
               </a:defRPr>
             </a:pPr>
             <a:r>
-              <a:t>Results — on SYNTHETIC data (labelled)</a:t>
-            </a:r>
-          </a:p>
-        </p:txBody>
-      </p:sp>
-      <p:pic>
-        <p:nvPicPr>
-          <p:cNvPr id="3" name="Picture 2" descr="ml_confusion_matrices.png"/>
-          <p:cNvPicPr>
-            <a:picLocks noChangeAspect="1"/>
-          </p:cNvPicPr>
+              <a:t>Defense-in-depth cybersecurity &amp; encrypted KYC vault</a:t>
+            </a:r>
+          </a:p>
+        </p:txBody>
+      </p:sp>
+      <p:sp>
+        <p:nvSpPr>
+          <p:cNvPr id="3" name="TextBox 2"/>
+          <p:cNvSpPr txBox="1"/>
           <p:nvPr/>
-        </p:nvPicPr>
-        <p:blipFill>
-          <a:blip r:embed="rId2"/>
-          <a:stretch>
-            <a:fillRect/>
-          </a:stretch>
-        </p:blipFill>
+        </p:nvSpPr>
         <p:spPr>
           <a:xfrm>
-            <a:off x="457200" y="1280160"/>
-            <a:ext cx="5669280" cy="2805174"/>
-          </a:xfrm>
-          <a:prstGeom prst="rect">
-            <a:avLst/>
-          </a:prstGeom>
-        </p:spPr>
-      </p:pic>
-      <p:pic>
-        <p:nvPicPr>
-          <p:cNvPr id="4" name="Picture 3" descr="ml_risk_distribution.png"/>
-          <p:cNvPicPr>
-            <a:picLocks noChangeAspect="1"/>
-          </p:cNvPicPr>
-          <p:nvPr/>
-        </p:nvPicPr>
-        <p:blipFill>
-          <a:blip r:embed="rId3"/>
-          <a:stretch>
-            <a:fillRect/>
-          </a:stretch>
-        </p:blipFill>
-        <p:spPr>
-          <a:xfrm>
-            <a:off x="6309360" y="1280160"/>
-            <a:ext cx="5669280" cy="2248282"/>
-          </a:xfrm>
-          <a:prstGeom prst="rect">
-            <a:avLst/>
-          </a:prstGeom>
-        </p:spPr>
-      </p:pic>
-      <p:sp>
-        <p:nvSpPr>
-          <p:cNvPr id="5" name="TextBox 4"/>
-          <p:cNvSpPr txBox="1"/>
-          <p:nvPr/>
-        </p:nvSpPr>
-        <p:spPr>
-          <a:xfrm>
-            <a:off x="548640" y="5120640"/>
-            <a:ext cx="11064240" cy="4937760"/>
+            <a:off x="548640" y="1325880"/>
+            <a:ext cx="11064240" cy="5029200"/>
           </a:xfrm>
           <a:prstGeom prst="rect">
             <a:avLst/>
@@ -6193,14 +6096,14 @@
               <a:spcAft>
                 <a:spcPts val="600"/>
               </a:spcAft>
-              <a:defRPr sz="1300" b="1">
+              <a:defRPr sz="1500" b="0">
                 <a:solidFill>
                   <a:srgbClr val="E2E8F0"/>
                 </a:solidFill>
               </a:defRPr>
             </a:pPr>
             <a:r>
-              <a:t>Category 0.733 vs 0.185 baseline · Severity 0.846 vs 0.328 · SLA 0.794 vs 0.625 (n=195/195/160)</a:t>
+              <a:t>Zero localStorage tokens: HttpOnly; SameSite=Strict session cookie + verified in-memory bridge</a:t>
             </a:r>
           </a:p>
           <a:p>
@@ -6208,14 +6111,59 @@
               <a:spcAft>
                 <a:spcPts val="600"/>
               </a:spcAft>
-              <a:defRPr sz="1300" b="0">
-                <a:solidFill>
-                  <a:srgbClr val="F59E0B"/>
+              <a:defRPr sz="1500" b="1">
+                <a:solidFill>
+                  <a:srgbClr val="34D399"/>
                 </a:solidFill>
               </a:defRPr>
             </a:pPr>
             <a:r>
-              <a:t>Latency measured LOCAL, SYNTHETIC: p50 3.1 ms · p95 4.5 ms · 100 reads · 0 errors — not a UGVCL figure</a:t>
+              <a:t>Strict upload verification: %PDF-, PNG, JPEG &amp; UTF-8 .txt magic-byte checks (blocks disguised EXEs)</a:t>
+            </a:r>
+          </a:p>
+          <a:p>
+            <a:pPr>
+              <a:spcAft>
+                <a:spcPts val="600"/>
+              </a:spcAft>
+              <a:defRPr sz="1500" b="0">
+                <a:solidFill>
+                  <a:srgbClr val="E2E8F0"/>
+                </a:solidFill>
+              </a:defRPr>
+            </a:pPr>
+            <a:r>
+              <a:t>Always-on VFENC1 HKDF-SHA256 + AES-256-GCM vault encryption (uploads_encrypted/) + field cipher</a:t>
+            </a:r>
+          </a:p>
+          <a:p>
+            <a:pPr>
+              <a:spcAft>
+                <a:spcPts val="600"/>
+              </a:spcAft>
+              <a:defRPr sz="1500" b="0">
+                <a:solidFill>
+                  <a:srgbClr val="E2E8F0"/>
+                </a:solidFill>
+              </a:defRPr>
+            </a:pPr>
+            <a:r>
+              <a:t>Fork-proof SHA-256 hash-chained AuditLog (AuditChainHead) + ArcSight/Wazuh CEF:0 SIEM export</a:t>
+            </a:r>
+          </a:p>
+          <a:p>
+            <a:pPr>
+              <a:spcAft>
+                <a:spcPts val="600"/>
+              </a:spcAft>
+              <a:defRPr sz="1500" b="0">
+                <a:solidFill>
+                  <a:srgbClr val="E2E8F0"/>
+                </a:solidFill>
+              </a:defRPr>
+            </a:pPr>
+            <a:r>
+              <a:t>CSP, HSTS, X-Frame-Options: DENY, 100% parameterized ORM queries &amp; 4-VLAN Zero-Trust design</a:t>
             </a:r>
           </a:p>
         </p:txBody>

</xml_diff>

<commit_message>
Docs & PPTX viva hardening: backup/restore drill framing, dual-auth & LOC navigation map (feature freeze)
</commit_message>
<xml_diff>
--- a/docs/deck/VidyutFlow_PS000125.pptx
+++ b/docs/deck/VidyutFlow_PS000125.pptx
@@ -653,7 +653,7 @@
           <a:lstStyle/>
           <a:p>
             <a:r>
-              <a:t>CI template at docs/ci.yml mirrors `make coverage`, `make train`, `make dr-proof`, and `make build`.</a:t>
+              <a:t>Emphasize behavioral end-to-end tests (submit -&gt; validate -&gt; triage -&gt; route -&gt; offline sync -&gt; approve -&gt; hash-chain audit) rather than raw check counts.</a:t>
             </a:r>
           </a:p>
         </p:txBody>
@@ -933,7 +933,7 @@
           <a:lstStyle/>
           <a:p>
             <a:r>
-              <a:t>Vendor SKUs and datasheets documented in docs/INFRASTRUCTURE_BOM_SOURCES.md (Element14, Evelta, Dell R650xs, FortiGate 60F).</a:t>
+              <a:t>Present strictly as a costed hardware &amp; network reference proposal backed by vendor SKUs/datasheets in docs/INFRASTRUCTURE_BOM_SOURCES.md.</a:t>
             </a:r>
           </a:p>
         </p:txBody>
@@ -1073,7 +1073,7 @@
           <a:lstStyle/>
           <a:p>
             <a:r>
-              <a:t>Evidence in docs/verification/r4-cold-start-dr-proof.txt and r4-dr-failover-drill.txt.</a:t>
+              <a:t>Call this what it is: a verified backup, tamper-rejection, and local SQLite restore drill — NOT multi-server HA failover (PostgreSQL 16 streaming HA is Tier 2/3 in INFRASTRUCTURE_ROADMAP.md).</a:t>
             </a:r>
           </a:p>
         </p:txBody>
@@ -4640,7 +4640,7 @@
               </a:defRPr>
             </a:pPr>
             <a:r>
-              <a:t>100% API test coverage &amp; phased UGVCL rollout</a:t>
+              <a:t>Behavioral API verification &amp; phased UGVCL rollout</a:t>
             </a:r>
           </a:p>
         </p:txBody>
@@ -4678,7 +4678,7 @@
               </a:defRPr>
             </a:pPr>
             <a:r>
-              <a:t>124 backend pytest tests · 55 / 55 (100%) OpenAPI HTTP operations tested · 38 frontend test suites</a:t>
+              <a:t>End-to-end behavioral pytest coverage across all 55 / 55 OpenAPI operations (124 repeatable tests)</a:t>
             </a:r>
           </a:p>
           <a:p>
@@ -5294,7 +5294,7 @@
               </a:defRPr>
             </a:pPr>
             <a:r>
-              <a:t>Cloud-to-edge IT infrastructure &amp; costed BOM</a:t>
+              <a:t>Cloud-to-edge IT infrastructure (costed reference proposal)</a:t>
             </a:r>
           </a:p>
         </p:txBody>
@@ -5356,7 +5356,7 @@
               </a:defRPr>
             </a:pPr>
             <a:r>
-              <a:t>Substation Edge: 500× RPi4 + Quectel EC200U-CN Dual-SIM 4G (₹8,000 × 500 = ₹40L) · MPLS + FortiGate 60F SD-WAN · Tiers: ₹14.80L / ₹1.18Cr / ₹7.45Cr</a:t>
+              <a:t>Costed 3-tier reference plan: 500× RPi4 + Quectel EC200U-CN 4G (₹8,000 × 500 = ₹40L) · MPLS + FortiGate 60F SD-WAN · ₹14.80L / ₹1.18Cr / ₹7.45Cr</a:t>
             </a:r>
           </a:p>
         </p:txBody>
@@ -5576,7 +5576,7 @@
               </a:defRPr>
             </a:pPr>
             <a:r>
-              <a:t>Cold-start &lt;60s primary → hot-standby DR failover</a:t>
+              <a:t>Automated backup, SHA-256 verify &amp; local restore drill</a:t>
             </a:r>
           </a:p>
         </p:txBody>
@@ -5614,7 +5614,7 @@
               </a:defRPr>
             </a:pPr>
             <a:r>
-              <a:t>Live API (POST /v1/system/dr-failover-drill) &amp; cold-start script (cold_start_dr_proof.py)</a:t>
+              <a:t>Live backup &amp; restore verification (POST /v1/system/dr-failover-drill &amp; cold_start_dr_proof.py)</a:t>
             </a:r>
           </a:p>
           <a:p>
@@ -5641,7 +5641,7 @@
               </a:defRPr>
             </a:pPr>
             <a:r>
-              <a:t>1 · Boot fresh DB &amp; submit live citizen request (zero manual container pre-setup)</a:t>
+              <a:t>1 · Boot fresh SQLite DB &amp; submit live citizen request</a:t>
             </a:r>
           </a:p>
           <a:p>
@@ -5656,7 +5656,7 @@
               </a:defRPr>
             </a:pPr>
             <a:r>
-              <a:t>2 · Replicate SHA-256 checksummed snapshot to isolated hot-standby vault</a:t>
+              <a:t>2 · Write SHA-256 checksummed snapshot &amp; reject 1-byte tampered copies (restore_drill.sh)</a:t>
             </a:r>
           </a:p>
           <a:p>
@@ -5671,7 +5671,7 @@
               </a:defRPr>
             </a:pPr>
             <a:r>
-              <a:t>3 · Destroy primary DB → verify SHA-256 → promote standby → PRAGMA integrity_check = ok</a:t>
+              <a:t>3 · Wipe primary SQLite file → verify SHA-256 → restore snapshot → PRAGMA integrity_check = ok</a:t>
             </a:r>
           </a:p>
           <a:p>
@@ -5686,7 +5686,7 @@
               </a:defRPr>
             </a:pPr>
             <a:r>
-              <a:t>Measured local SQLite RTO: ~3.5 ms (&lt; 60s target) · 0 records lost</a:t>
+              <a:t>0 records lost in local restore drill · Multi-node PostgreSQL 16 streaming HA is Circle/DISCOM tier</a:t>
             </a:r>
           </a:p>
         </p:txBody>

</xml_diff>

<commit_message>
Enforce CSP header in main.py, align 5 seeded workflow templates & SameSite=Lax across docs/deck, add VIVA_QUESTION_BANK.md
</commit_message>
<xml_diff>
--- a/docs/deck/VidyutFlow_PS000125.pptx
+++ b/docs/deck/VidyutFlow_PS000125.pptx
@@ -5470,7 +5470,7 @@
               </a:defRPr>
             </a:pPr>
             <a:r>
-              <a:t>4 languages (English, Gujarati, Hindi, Marathi) + 7 configurable utility workflows</a:t>
+              <a:t>4 languages (English, Gujarati, Hindi, Marathi) + 5 seeded configurable utility workflows</a:t>
             </a:r>
           </a:p>
           <a:p>
@@ -6103,7 +6103,7 @@
               </a:defRPr>
             </a:pPr>
             <a:r>
-              <a:t>Zero localStorage tokens: HttpOnly; SameSite=Strict session cookie + verified in-memory bridge</a:t>
+              <a:t>Zero localStorage tokens: HttpOnly; SameSite=Lax session cookie + verified in-memory bridge</a:t>
             </a:r>
           </a:p>
           <a:p>

</xml_diff>